<commit_message>
Add team members Taiwo Ayorinde and Oluwaseyi Ogunrinola
Application answers and the deck's team slide (three cards). Contact
details stay out of the public repo.

Co-Authored-By: Claude Opus 5.5 <noreply@anthropic.com>
</commit_message>
<xml_diff>
--- a/submission/N-ATLAS_Dev_Kit_Pitch.pptx
+++ b/submission/N-ATLAS_Dev_Kit_Pitch.pptx
@@ -120,39 +120,39 @@
   <p:extLst>
     <p:ext uri="{521415D9-36F7-43E2-AB2F-B90AF26B5E84}">
       <p14:sectionLst xmlns:p14="http://schemas.microsoft.com/office/powerpoint/2010/main">
-        <p14:section name="Opening" id="{7633bf2f-fb1d-440e-b864-a5adc447cdd5}">
+        <p14:section name="Opening" id="{c3553bc2-3069-ab03-4dd2-1656b8452a43}">
           <p14:sldIdLst>
             <p14:sldId id="256"/>
           </p14:sldIdLst>
         </p14:section>
-        <p14:section name="Problem and solution" id="{7e839103-e8ad-e80a-1345-dc6594c04622}">
+        <p14:section name="Problem and solution" id="{0250328c-d189-55d2-c5df-434bda625797}">
           <p14:sldIdLst>
             <p14:sldId id="257"/>
             <p14:sldId id="258"/>
           </p14:sldIdLst>
         </p14:section>
-        <p14:section name="How it works" id="{27598294-01ff-8169-4960-eed0632f004e}">
+        <p14:section name="How it works" id="{1d9bd421-6138-1874-3765-6c91b8da0a5b}">
           <p14:sldIdLst>
             <p14:sldId id="259"/>
             <p14:sldId id="260"/>
             <p14:sldId id="261"/>
           </p14:sldIdLst>
         </p14:section>
-        <p14:section name="Evidence" id="{28b97c20-34ab-09af-3df2-0016172bff54}">
+        <p14:section name="Evidence" id="{77c93d1c-aa76-9b83-ed20-7cd7d8bda62c}">
           <p14:sldIdLst>
             <p14:sldId id="262"/>
             <p14:sldId id="263"/>
             <p14:sldId id="264"/>
           </p14:sldIdLst>
         </p14:section>
-        <p14:section name="Impact and growth" id="{9e504dbe-2438-3e43-4d40-324b314db51e}">
+        <p14:section name="Impact and growth" id="{109a71ec-b4fe-aebc-1aeb-340af2f111b5}">
           <p14:sldIdLst>
             <p14:sldId id="265"/>
             <p14:sldId id="266"/>
             <p14:sldId id="267"/>
           </p14:sldIdLst>
         </p14:section>
-        <p14:section name="Closing" id="{7de16a43-2255-5e28-2edd-3ce43d6c2390}">
+        <p14:section name="Closing" id="{cc9c7401-adb0-9485-09f9-f93ba2e7f74c}">
           <p14:sldIdLst>
             <p14:sldId id="268"/>
             <p14:sldId id="269"/>
@@ -914,7 +914,7 @@
           <a:p>
             <a:r>
               <a:rPr lang="en-US" dirty="0"/>
-              <a:t>Introduce the team. Replace the placeholder card with the second team member before submitting.</a:t>
+              <a:t>Introduce the team: Abdulrasheed Bello, CTO of Peachel Innovations Limited and lead developer; Taiwo Ayorinde, software developer; Oluwaseyi Ogunrinola, entrepreneur.</a:t>
             </a:r>
             <a:endParaRPr lang="en-US" dirty="0"/>
           </a:p>
@@ -5606,11 +5606,11 @@
         <p:spPr>
           <a:xfrm>
             <a:off x="548640" y="1463040"/>
-            <a:ext cx="5364328" cy="3840480"/>
+            <a:ext cx="3484778" cy="4114800"/>
           </a:xfrm>
           <a:prstGeom prst="roundRect">
             <a:avLst>
-              <a:gd name="adj" fmla="val 2857"/>
+              <a:gd name="adj" fmla="val 3149"/>
             </a:avLst>
           </a:prstGeom>
           <a:solidFill>
@@ -5627,8 +5627,8 @@
         </p:nvSpPr>
         <p:spPr>
           <a:xfrm>
-            <a:off x="914400" y="1783080"/>
-            <a:ext cx="1005840" cy="1005840"/>
+            <a:off x="850392" y="1764792"/>
+            <a:ext cx="768096" cy="768096"/>
           </a:xfrm>
           <a:prstGeom prst="ellipse">
             <a:avLst/>
@@ -5649,8 +5649,8 @@
         </p:nvSpPr>
         <p:spPr>
           <a:xfrm>
-            <a:off x="1075334" y="1944014"/>
-            <a:ext cx="683971" cy="683971"/>
+            <a:off x="973287" y="1887687"/>
+            <a:ext cx="522305" cy="522305"/>
           </a:xfrm>
           <a:prstGeom prst="ellipse">
             <a:avLst/>
@@ -5673,8 +5673,8 @@
         </p:nvSpPr>
         <p:spPr>
           <a:xfrm>
-            <a:off x="1236269" y="2104949"/>
-            <a:ext cx="362102" cy="362102"/>
+            <a:off x="1096183" y="2010583"/>
+            <a:ext cx="276515" cy="276515"/>
           </a:xfrm>
           <a:prstGeom prst="ellipse">
             <a:avLst/>
@@ -5697,8 +5697,8 @@
         </p:nvSpPr>
         <p:spPr>
           <a:xfrm>
-            <a:off x="1367028" y="2235708"/>
-            <a:ext cx="100584" cy="100584"/>
+            <a:off x="1196035" y="2110435"/>
+            <a:ext cx="76810" cy="76810"/>
           </a:xfrm>
           <a:prstGeom prst="ellipse">
             <a:avLst/>
@@ -5717,24 +5717,24 @@
         </p:nvSpPr>
         <p:spPr>
           <a:xfrm>
-            <a:off x="2194560" y="1828800"/>
-            <a:ext cx="3444088" cy="822960"/>
-          </a:xfrm>
-          <a:prstGeom prst="rect">
-            <a:avLst/>
-          </a:prstGeom>
-          <a:noFill/>
-          <a:ln/>
-        </p:spPr>
-        <p:txBody>
-          <a:bodyPr wrap="square" lIns="0" tIns="0" rIns="0" bIns="0" rtlCol="0" anchor="ctr"/>
+            <a:off x="868680" y="2743200"/>
+            <a:ext cx="2844698" cy="777240"/>
+          </a:xfrm>
+          <a:prstGeom prst="rect">
+            <a:avLst/>
+          </a:prstGeom>
+          <a:noFill/>
+          <a:ln/>
+        </p:spPr>
+        <p:txBody>
+          <a:bodyPr wrap="square" lIns="0" tIns="0" rIns="0" bIns="0" rtlCol="0" anchor="t"/>
           <a:lstStyle/>
           <a:p>
             <a:pPr indent="0" marL="0">
               <a:buNone/>
             </a:pPr>
             <a:r>
-              <a:rPr lang="en-US" sz="2000" b="1" dirty="0">
+              <a:rPr lang="en-US" sz="1900" b="1" dirty="0">
                 <a:solidFill>
                   <a:schemeClr val="tx2"/>
                 </a:solidFill>
@@ -5744,7 +5744,7 @@
               </a:rPr>
               <a:t>Abdulrasheed Akinbola Bello (Akindats)</a:t>
             </a:r>
-            <a:endParaRPr lang="en-US" sz="2000" dirty="0"/>
+            <a:endParaRPr lang="en-US" sz="1900" dirty="0"/>
           </a:p>
         </p:txBody>
       </p:sp>
@@ -5756,8 +5756,8 @@
         </p:nvSpPr>
         <p:spPr>
           <a:xfrm>
-            <a:off x="914400" y="2971800"/>
-            <a:ext cx="4632808" cy="411480"/>
+            <a:off x="868680" y="3566160"/>
+            <a:ext cx="2844698" cy="640080"/>
           </a:xfrm>
           <a:prstGeom prst="rect">
             <a:avLst/>
@@ -5773,7 +5773,7 @@
               <a:buNone/>
             </a:pPr>
             <a:r>
-              <a:rPr lang="en-US" sz="1600" b="1" dirty="0">
+              <a:rPr lang="en-US" sz="1500" b="1" dirty="0">
                 <a:solidFill>
                   <a:schemeClr val="tx1"/>
                 </a:solidFill>
@@ -5783,7 +5783,7 @@
               </a:rPr>
               <a:t>CTO, Peachel Innovations Limited · lead developer</a:t>
             </a:r>
-            <a:endParaRPr lang="en-US" sz="1600" dirty="0"/>
+            <a:endParaRPr lang="en-US" sz="1500" dirty="0"/>
           </a:p>
         </p:txBody>
       </p:sp>
@@ -5795,8 +5795,8 @@
         </p:nvSpPr>
         <p:spPr>
           <a:xfrm>
-            <a:off x="914400" y="3474720"/>
-            <a:ext cx="4632808" cy="1463040"/>
+            <a:off x="868680" y="4251960"/>
+            <a:ext cx="2844698" cy="1234440"/>
           </a:xfrm>
           <a:prstGeom prst="rect">
             <a:avLst/>
@@ -5812,9 +5812,9 @@
               <a:buNone/>
             </a:pPr>
             <a:r>
-              <a:rPr lang="en-US" sz="1500" dirty="0">
-                <a:solidFill>
-                  <a:schemeClr val="tx1"/>
+              <a:rPr lang="en-US" sz="1400" dirty="0">
+                <a:solidFill>
+                  <a:schemeClr val="accent5"/>
                 </a:solidFill>
                 <a:latin typeface="Calibri" pitchFamily="34" charset="0"/>
                 <a:ea typeface="Calibri" pitchFamily="34" charset="-122"/>
@@ -5822,47 +5822,132 @@
               </a:rPr>
               <a:t>Software developer in C#/.NET, Next.js and TypeScript. Builds commercial Autodesk Revit, AutoCAD and Civil 3D plugins; technical lead for ConTech Nigeria.</a:t>
             </a:r>
-            <a:endParaRPr lang="en-US" sz="1500" dirty="0"/>
-          </a:p>
-        </p:txBody>
-      </p:sp>
-      <p:sp>
-        <p:nvSpPr>
-          <p:cNvPr id="11" name="placeholder-card-226"/>
+            <a:endParaRPr lang="en-US" sz="1400" dirty="0"/>
+          </a:p>
+        </p:txBody>
+      </p:sp>
+      <p:sp>
+        <p:nvSpPr>
+          <p:cNvPr id="11" name="card-226"/>
           <p:cNvSpPr/>
           <p:nvPr/>
         </p:nvSpPr>
         <p:spPr>
           <a:xfrm>
-            <a:off x="6278728" y="1463040"/>
-            <a:ext cx="5364328" cy="3840480"/>
+            <a:off x="4353458" y="1463040"/>
+            <a:ext cx="3484778" cy="4114800"/>
           </a:xfrm>
           <a:prstGeom prst="roundRect">
             <a:avLst>
-              <a:gd name="adj" fmla="val 2857"/>
+              <a:gd name="adj" fmla="val 3149"/>
             </a:avLst>
           </a:prstGeom>
           <a:solidFill>
-            <a:schemeClr val="bg1"/>
+            <a:schemeClr val="bg2"/>
           </a:solidFill>
-          <a:ln w="12700">
+          <a:ln/>
+        </p:spPr>
+      </p:sp>
+      <p:sp>
+        <p:nvSpPr>
+          <p:cNvPr id="12" name="adire-227"/>
+          <p:cNvSpPr/>
+          <p:nvPr/>
+        </p:nvSpPr>
+        <p:spPr>
+          <a:xfrm>
+            <a:off x="4655210" y="1764792"/>
+            <a:ext cx="768096" cy="768096"/>
+          </a:xfrm>
+          <a:prstGeom prst="ellipse">
+            <a:avLst/>
+          </a:prstGeom>
+          <a:ln w="19050">
             <a:solidFill>
-              <a:schemeClr val="accent5"/>
+              <a:schemeClr val="tx2"/>
             </a:solidFill>
-            <a:prstDash val="dash"/>
+            <a:prstDash val="solid"/>
           </a:ln>
         </p:spPr>
       </p:sp>
       <p:sp>
         <p:nvSpPr>
-          <p:cNvPr id="12" name="text-227"/>
-          <p:cNvSpPr txBox="1"/>
-          <p:nvPr/>
-        </p:nvSpPr>
-        <p:spPr>
-          <a:xfrm>
-            <a:off x="6644488" y="3108960"/>
-            <a:ext cx="4632808" cy="548640"/>
+          <p:cNvPr id="13" name="adire-228"/>
+          <p:cNvSpPr/>
+          <p:nvPr/>
+        </p:nvSpPr>
+        <p:spPr>
+          <a:xfrm>
+            <a:off x="4778106" y="1887687"/>
+            <a:ext cx="522305" cy="522305"/>
+          </a:xfrm>
+          <a:prstGeom prst="ellipse">
+            <a:avLst/>
+          </a:prstGeom>
+          <a:ln w="19050">
+            <a:solidFill>
+              <a:schemeClr val="tx2">
+                <a:alpha val="90000"/>
+              </a:schemeClr>
+            </a:solidFill>
+            <a:prstDash val="solid"/>
+          </a:ln>
+        </p:spPr>
+      </p:sp>
+      <p:sp>
+        <p:nvSpPr>
+          <p:cNvPr id="14" name="adire-229"/>
+          <p:cNvSpPr/>
+          <p:nvPr/>
+        </p:nvSpPr>
+        <p:spPr>
+          <a:xfrm>
+            <a:off x="4901001" y="2010583"/>
+            <a:ext cx="276515" cy="276515"/>
+          </a:xfrm>
+          <a:prstGeom prst="ellipse">
+            <a:avLst/>
+          </a:prstGeom>
+          <a:ln w="19050">
+            <a:solidFill>
+              <a:schemeClr val="tx2">
+                <a:alpha val="80000"/>
+              </a:schemeClr>
+            </a:solidFill>
+            <a:prstDash val="solid"/>
+          </a:ln>
+        </p:spPr>
+      </p:sp>
+      <p:sp>
+        <p:nvSpPr>
+          <p:cNvPr id="15" name="adire-dot-230"/>
+          <p:cNvSpPr/>
+          <p:nvPr/>
+        </p:nvSpPr>
+        <p:spPr>
+          <a:xfrm>
+            <a:off x="5000854" y="2110435"/>
+            <a:ext cx="76810" cy="76810"/>
+          </a:xfrm>
+          <a:prstGeom prst="ellipse">
+            <a:avLst/>
+          </a:prstGeom>
+          <a:solidFill>
+            <a:schemeClr val="accent2"/>
+          </a:solidFill>
+          <a:ln/>
+        </p:spPr>
+      </p:sp>
+      <p:sp>
+        <p:nvSpPr>
+          <p:cNvPr id="16" name="text-231"/>
+          <p:cNvSpPr txBox="1"/>
+          <p:nvPr/>
+        </p:nvSpPr>
+        <p:spPr>
+          <a:xfrm>
+            <a:off x="4673498" y="2743200"/>
+            <a:ext cx="2844698" cy="777240"/>
           </a:xfrm>
           <a:prstGeom prst="rect">
             <a:avLst/>
@@ -5874,34 +5959,34 @@
           <a:bodyPr wrap="square" lIns="0" tIns="0" rIns="0" bIns="0" rtlCol="0" anchor="t"/>
           <a:lstStyle/>
           <a:p>
-            <a:pPr algn="ctr" indent="0" marL="0">
-              <a:buNone/>
-            </a:pPr>
-            <a:r>
-              <a:rPr lang="en-US" sz="1800" i="1" dirty="0">
-                <a:solidFill>
-                  <a:schemeClr val="accent6"/>
-                </a:solidFill>
-                <a:latin typeface="Calibri" pitchFamily="34" charset="0"/>
-                <a:ea typeface="Calibri" pitchFamily="34" charset="-122"/>
-                <a:cs typeface="Calibri" pitchFamily="34" charset="-120"/>
-              </a:rPr>
-              <a:t>[Teammate: name, role and background]</a:t>
-            </a:r>
-            <a:endParaRPr lang="en-US" sz="1800" dirty="0"/>
-          </a:p>
-        </p:txBody>
-      </p:sp>
-      <p:sp>
-        <p:nvSpPr>
-          <p:cNvPr id="13" name="text-228"/>
-          <p:cNvSpPr txBox="1"/>
-          <p:nvPr/>
-        </p:nvSpPr>
-        <p:spPr>
-          <a:xfrm>
-            <a:off x="548640" y="5577840"/>
-            <a:ext cx="11094415" cy="365760"/>
+            <a:pPr indent="0" marL="0">
+              <a:buNone/>
+            </a:pPr>
+            <a:r>
+              <a:rPr lang="en-US" sz="1900" b="1" dirty="0">
+                <a:solidFill>
+                  <a:schemeClr val="tx2"/>
+                </a:solidFill>
+                <a:latin typeface="Calibri" pitchFamily="34" charset="0"/>
+                <a:ea typeface="Calibri" pitchFamily="34" charset="-122"/>
+                <a:cs typeface="Calibri" pitchFamily="34" charset="-120"/>
+              </a:rPr>
+              <a:t>Taiwo Ayorinde</a:t>
+            </a:r>
+            <a:endParaRPr lang="en-US" sz="1900" dirty="0"/>
+          </a:p>
+        </p:txBody>
+      </p:sp>
+      <p:sp>
+        <p:nvSpPr>
+          <p:cNvPr id="17" name="text-232"/>
+          <p:cNvSpPr txBox="1"/>
+          <p:nvPr/>
+        </p:nvSpPr>
+        <p:spPr>
+          <a:xfrm>
+            <a:off x="4673498" y="3566160"/>
+            <a:ext cx="2844698" cy="640080"/>
           </a:xfrm>
           <a:prstGeom prst="rect">
             <a:avLst/>
@@ -5917,6 +6002,45 @@
               <a:buNone/>
             </a:pPr>
             <a:r>
+              <a:rPr lang="en-US" sz="1500" b="1" dirty="0">
+                <a:solidFill>
+                  <a:schemeClr val="tx1"/>
+                </a:solidFill>
+                <a:latin typeface="Calibri" pitchFamily="34" charset="0"/>
+                <a:ea typeface="Calibri" pitchFamily="34" charset="-122"/>
+                <a:cs typeface="Calibri" pitchFamily="34" charset="-120"/>
+              </a:rPr>
+              <a:t>Software Developer/Engineer</a:t>
+            </a:r>
+            <a:endParaRPr lang="en-US" sz="1500" dirty="0"/>
+          </a:p>
+        </p:txBody>
+      </p:sp>
+      <p:sp>
+        <p:nvSpPr>
+          <p:cNvPr id="18" name="text-233"/>
+          <p:cNvSpPr txBox="1"/>
+          <p:nvPr/>
+        </p:nvSpPr>
+        <p:spPr>
+          <a:xfrm>
+            <a:off x="4673498" y="4251960"/>
+            <a:ext cx="2844698" cy="1234440"/>
+          </a:xfrm>
+          <a:prstGeom prst="rect">
+            <a:avLst/>
+          </a:prstGeom>
+          <a:noFill/>
+          <a:ln/>
+        </p:spPr>
+        <p:txBody>
+          <a:bodyPr wrap="square" lIns="0" tIns="0" rIns="0" bIns="0" rtlCol="0" anchor="t"/>
+          <a:lstStyle/>
+          <a:p>
+            <a:pPr indent="0" marL="0">
+              <a:buNone/>
+            </a:pPr>
+            <a:r>
               <a:rPr lang="en-US" sz="1400" dirty="0">
                 <a:solidFill>
                   <a:schemeClr val="accent5"/>
@@ -5925,7 +6049,236 @@
                 <a:ea typeface="Calibri" pitchFamily="34" charset="-122"/>
                 <a:cs typeface="Calibri" pitchFamily="34" charset="-120"/>
               </a:rPr>
-              <a:t>The Innovation &amp; Enterprise track requires 2 to 5 team members.</a:t>
+              <a:t>Lagos</a:t>
+            </a:r>
+            <a:endParaRPr lang="en-US" sz="1400" dirty="0"/>
+          </a:p>
+        </p:txBody>
+      </p:sp>
+      <p:sp>
+        <p:nvSpPr>
+          <p:cNvPr id="19" name="card-234"/>
+          <p:cNvSpPr/>
+          <p:nvPr/>
+        </p:nvSpPr>
+        <p:spPr>
+          <a:xfrm>
+            <a:off x="8158277" y="1463040"/>
+            <a:ext cx="3484778" cy="4114800"/>
+          </a:xfrm>
+          <a:prstGeom prst="roundRect">
+            <a:avLst>
+              <a:gd name="adj" fmla="val 3149"/>
+            </a:avLst>
+          </a:prstGeom>
+          <a:solidFill>
+            <a:schemeClr val="bg2"/>
+          </a:solidFill>
+          <a:ln/>
+        </p:spPr>
+      </p:sp>
+      <p:sp>
+        <p:nvSpPr>
+          <p:cNvPr id="20" name="adire-235"/>
+          <p:cNvSpPr/>
+          <p:nvPr/>
+        </p:nvSpPr>
+        <p:spPr>
+          <a:xfrm>
+            <a:off x="8460029" y="1764792"/>
+            <a:ext cx="768096" cy="768096"/>
+          </a:xfrm>
+          <a:prstGeom prst="ellipse">
+            <a:avLst/>
+          </a:prstGeom>
+          <a:ln w="19050">
+            <a:solidFill>
+              <a:schemeClr val="tx2"/>
+            </a:solidFill>
+            <a:prstDash val="solid"/>
+          </a:ln>
+        </p:spPr>
+      </p:sp>
+      <p:sp>
+        <p:nvSpPr>
+          <p:cNvPr id="21" name="adire-236"/>
+          <p:cNvSpPr/>
+          <p:nvPr/>
+        </p:nvSpPr>
+        <p:spPr>
+          <a:xfrm>
+            <a:off x="8582924" y="1887687"/>
+            <a:ext cx="522305" cy="522305"/>
+          </a:xfrm>
+          <a:prstGeom prst="ellipse">
+            <a:avLst/>
+          </a:prstGeom>
+          <a:ln w="19050">
+            <a:solidFill>
+              <a:schemeClr val="tx2">
+                <a:alpha val="90000"/>
+              </a:schemeClr>
+            </a:solidFill>
+            <a:prstDash val="solid"/>
+          </a:ln>
+        </p:spPr>
+      </p:sp>
+      <p:sp>
+        <p:nvSpPr>
+          <p:cNvPr id="22" name="adire-237"/>
+          <p:cNvSpPr/>
+          <p:nvPr/>
+        </p:nvSpPr>
+        <p:spPr>
+          <a:xfrm>
+            <a:off x="8705820" y="2010583"/>
+            <a:ext cx="276515" cy="276515"/>
+          </a:xfrm>
+          <a:prstGeom prst="ellipse">
+            <a:avLst/>
+          </a:prstGeom>
+          <a:ln w="19050">
+            <a:solidFill>
+              <a:schemeClr val="tx2">
+                <a:alpha val="80000"/>
+              </a:schemeClr>
+            </a:solidFill>
+            <a:prstDash val="solid"/>
+          </a:ln>
+        </p:spPr>
+      </p:sp>
+      <p:sp>
+        <p:nvSpPr>
+          <p:cNvPr id="23" name="adire-dot-238"/>
+          <p:cNvSpPr/>
+          <p:nvPr/>
+        </p:nvSpPr>
+        <p:spPr>
+          <a:xfrm>
+            <a:off x="8805672" y="2110435"/>
+            <a:ext cx="76810" cy="76810"/>
+          </a:xfrm>
+          <a:prstGeom prst="ellipse">
+            <a:avLst/>
+          </a:prstGeom>
+          <a:solidFill>
+            <a:schemeClr val="accent2"/>
+          </a:solidFill>
+          <a:ln/>
+        </p:spPr>
+      </p:sp>
+      <p:sp>
+        <p:nvSpPr>
+          <p:cNvPr id="24" name="text-239"/>
+          <p:cNvSpPr txBox="1"/>
+          <p:nvPr/>
+        </p:nvSpPr>
+        <p:spPr>
+          <a:xfrm>
+            <a:off x="8478317" y="2743200"/>
+            <a:ext cx="2844698" cy="777240"/>
+          </a:xfrm>
+          <a:prstGeom prst="rect">
+            <a:avLst/>
+          </a:prstGeom>
+          <a:noFill/>
+          <a:ln/>
+        </p:spPr>
+        <p:txBody>
+          <a:bodyPr wrap="square" lIns="0" tIns="0" rIns="0" bIns="0" rtlCol="0" anchor="t"/>
+          <a:lstStyle/>
+          <a:p>
+            <a:pPr indent="0" marL="0">
+              <a:buNone/>
+            </a:pPr>
+            <a:r>
+              <a:rPr lang="en-US" sz="1900" b="1" dirty="0">
+                <a:solidFill>
+                  <a:schemeClr val="tx2"/>
+                </a:solidFill>
+                <a:latin typeface="Calibri" pitchFamily="34" charset="0"/>
+                <a:ea typeface="Calibri" pitchFamily="34" charset="-122"/>
+                <a:cs typeface="Calibri" pitchFamily="34" charset="-120"/>
+              </a:rPr>
+              <a:t>Oluwaseyi Ogunrinola</a:t>
+            </a:r>
+            <a:endParaRPr lang="en-US" sz="1900" dirty="0"/>
+          </a:p>
+        </p:txBody>
+      </p:sp>
+      <p:sp>
+        <p:nvSpPr>
+          <p:cNvPr id="25" name="text-240"/>
+          <p:cNvSpPr txBox="1"/>
+          <p:nvPr/>
+        </p:nvSpPr>
+        <p:spPr>
+          <a:xfrm>
+            <a:off x="8478317" y="3566160"/>
+            <a:ext cx="2844698" cy="640080"/>
+          </a:xfrm>
+          <a:prstGeom prst="rect">
+            <a:avLst/>
+          </a:prstGeom>
+          <a:noFill/>
+          <a:ln/>
+        </p:spPr>
+        <p:txBody>
+          <a:bodyPr wrap="square" lIns="0" tIns="0" rIns="0" bIns="0" rtlCol="0" anchor="t"/>
+          <a:lstStyle/>
+          <a:p>
+            <a:pPr indent="0" marL="0">
+              <a:buNone/>
+            </a:pPr>
+            <a:r>
+              <a:rPr lang="en-US" sz="1500" b="1" dirty="0">
+                <a:solidFill>
+                  <a:schemeClr val="tx1"/>
+                </a:solidFill>
+                <a:latin typeface="Calibri" pitchFamily="34" charset="0"/>
+                <a:ea typeface="Calibri" pitchFamily="34" charset="-122"/>
+                <a:cs typeface="Calibri" pitchFamily="34" charset="-120"/>
+              </a:rPr>
+              <a:t>Entrepreneur</a:t>
+            </a:r>
+            <a:endParaRPr lang="en-US" sz="1500" dirty="0"/>
+          </a:p>
+        </p:txBody>
+      </p:sp>
+      <p:sp>
+        <p:nvSpPr>
+          <p:cNvPr id="26" name="text-241"/>
+          <p:cNvSpPr txBox="1"/>
+          <p:nvPr/>
+        </p:nvSpPr>
+        <p:spPr>
+          <a:xfrm>
+            <a:off x="8478317" y="4251960"/>
+            <a:ext cx="2844698" cy="1234440"/>
+          </a:xfrm>
+          <a:prstGeom prst="rect">
+            <a:avLst/>
+          </a:prstGeom>
+          <a:noFill/>
+          <a:ln/>
+        </p:spPr>
+        <p:txBody>
+          <a:bodyPr wrap="square" lIns="0" tIns="0" rIns="0" bIns="0" rtlCol="0" anchor="t"/>
+          <a:lstStyle/>
+          <a:p>
+            <a:pPr indent="0" marL="0">
+              <a:buNone/>
+            </a:pPr>
+            <a:r>
+              <a:rPr lang="en-US" sz="1400" dirty="0">
+                <a:solidFill>
+                  <a:schemeClr val="accent5"/>
+                </a:solidFill>
+                <a:latin typeface="Calibri" pitchFamily="34" charset="0"/>
+                <a:ea typeface="Calibri" pitchFamily="34" charset="-122"/>
+                <a:cs typeface="Calibri" pitchFamily="34" charset="-120"/>
+              </a:rPr>
+              <a:t>Lagos</a:t>
             </a:r>
             <a:endParaRPr lang="en-US" sz="1400" dirty="0"/>
           </a:p>
@@ -6006,7 +6359,7 @@
       </p:grpSpPr>
       <p:sp>
         <p:nvSpPr>
-          <p:cNvPr id="2" name="adire-229"/>
+          <p:cNvPr id="2" name="adire-242"/>
           <p:cNvSpPr/>
           <p:nvPr/>
         </p:nvSpPr>
@@ -6030,7 +6383,7 @@
       </p:sp>
       <p:sp>
         <p:nvSpPr>
-          <p:cNvPr id="3" name="adire-230"/>
+          <p:cNvPr id="3" name="adire-243"/>
           <p:cNvSpPr/>
           <p:nvPr/>
         </p:nvSpPr>
@@ -6054,7 +6407,7 @@
       </p:sp>
       <p:sp>
         <p:nvSpPr>
-          <p:cNvPr id="4" name="adire-231"/>
+          <p:cNvPr id="4" name="adire-244"/>
           <p:cNvSpPr/>
           <p:nvPr/>
         </p:nvSpPr>
@@ -6078,7 +6431,7 @@
       </p:sp>
       <p:sp>
         <p:nvSpPr>
-          <p:cNvPr id="5" name="adire-dot-232"/>
+          <p:cNvPr id="5" name="adire-dot-245"/>
           <p:cNvSpPr/>
           <p:nvPr/>
         </p:nvSpPr>
@@ -6180,7 +6533,7 @@
       </p:sp>
       <p:sp>
         <p:nvSpPr>
-          <p:cNvPr id="8" name="text-233"/>
+          <p:cNvPr id="8" name="text-246"/>
           <p:cNvSpPr txBox="1"/>
           <p:nvPr/>
         </p:nvSpPr>
@@ -6219,7 +6572,7 @@
       </p:sp>
       <p:sp>
         <p:nvSpPr>
-          <p:cNvPr id="9" name="text-234"/>
+          <p:cNvPr id="9" name="text-247"/>
           <p:cNvSpPr txBox="1"/>
           <p:nvPr/>
         </p:nvSpPr>
@@ -6258,7 +6611,7 @@
       </p:sp>
       <p:sp>
         <p:nvSpPr>
-          <p:cNvPr id="10" name="text-235"/>
+          <p:cNvPr id="10" name="text-248"/>
           <p:cNvSpPr txBox="1"/>
           <p:nvPr/>
         </p:nvSpPr>
@@ -6297,7 +6650,7 @@
       </p:sp>
       <p:sp>
         <p:nvSpPr>
-          <p:cNvPr id="11" name="text-236"/>
+          <p:cNvPr id="11" name="text-249"/>
           <p:cNvSpPr txBox="1"/>
           <p:nvPr/>
         </p:nvSpPr>
@@ -6336,7 +6689,7 @@
       </p:sp>
       <p:sp>
         <p:nvSpPr>
-          <p:cNvPr id="12" name="text-237"/>
+          <p:cNvPr id="12" name="text-250"/>
           <p:cNvSpPr txBox="1"/>
           <p:nvPr/>
         </p:nvSpPr>
@@ -6375,7 +6728,7 @@
       </p:sp>
       <p:sp>
         <p:nvSpPr>
-          <p:cNvPr id="13" name="text-238"/>
+          <p:cNvPr id="13" name="text-251"/>
           <p:cNvSpPr txBox="1"/>
           <p:nvPr/>
         </p:nvSpPr>

</xml_diff>